<commit_message>
How It Works vector options: SFW brand colours, flat fills, no glow or gold
Backgrounds in Food Web Green #156826, Organic Cream #F4F1EA and Soil Brown
#4F3433; leaves, bacteria and flow arrows in the SFW greens; soft grass tufts
along the soil line; nutrient and sugar dots as plain cream dots.

Co-Authored-By: Claude Opus 5.5 <noreply@anthropic.com>
Claude-Session: https://claude.ai/code/session_01CYjAodEA27qxELVHfJ9B4V
</commit_message>
<xml_diff>
--- a/exports/stephanie/how-it-works/how-it-works-thumbnails-vector-options.pptx
+++ b/exports/stephanie/how-it-works/how-it-works-thumbnails-vector-options.pptx
@@ -515,7 +515,7 @@
           <a:lstStyle/>
           <a:p>
             <a:r>
-              <a:t>What is the Soil Food Web?, option A: Close-up: root tip with bacteria, fungi, a protozoan and a nematode. Vector illustration (no AI image generation).</a:t>
+              <a:t>What is the Soil Food Web?, option A: Close-up: root tip with bacteria, fungi, a protozoan and a nematode, on Soil Brown. Vector illustration (no AI image generation).</a:t>
             </a:r>
           </a:p>
         </p:txBody>
@@ -585,7 +585,7 @@
           <a:lstStyle/>
           <a:p>
             <a:r>
-              <a:t>Inhibiting Pests &amp; Diseases, option A: Close-up: root sleeved in beneficials, pathogen kept out. Vector illustration (no AI image generation).</a:t>
+              <a:t>Inhibiting Pests &amp; Diseases, option A: Close-up: root sleeved in beneficials, pathogen kept out, on Soil Brown. Vector illustration (no AI image generation).</a:t>
             </a:r>
           </a:p>
         </p:txBody>
@@ -655,7 +655,7 @@
           <a:lstStyle/>
           <a:p>
             <a:r>
-              <a:t>Inhibiting Pests &amp; Diseases, option B: The same as a specimen on cream. Vector illustration (no AI image generation).</a:t>
+              <a:t>Inhibiting Pests &amp; Diseases, option B: The same as a specimen on Food Web Green. Vector illustration (no AI image generation).</a:t>
             </a:r>
           </a:p>
         </p:txBody>
@@ -725,7 +725,7 @@
           <a:lstStyle/>
           <a:p>
             <a:r>
-              <a:t>Inhibiting Pests &amp; Diseases, option C: Tomato with a magnifier on its root zone. Vector illustration (no AI image generation).</a:t>
+              <a:t>Inhibiting Pests &amp; Diseases, option C: Tomato on Organic Cream, magnifier on its root zone. Vector illustration (no AI image generation).</a:t>
             </a:r>
           </a:p>
         </p:txBody>
@@ -795,7 +795,7 @@
           <a:lstStyle/>
           <a:p>
             <a:r>
-              <a:t>Sequestering Carbon, option A: Oak: carbon flows down the roots and fungal threads into dark soil clumps. Vector illustration (no AI image generation).</a:t>
+              <a:t>Sequestering Carbon, option A: Oak on Food Web Green: carbon flows down roots and fungal threads into dark soil clumps. Vector illustration (no AI image generation).</a:t>
             </a:r>
           </a:p>
         </p:txBody>
@@ -865,7 +865,7 @@
           <a:lstStyle/>
           <a:p>
             <a:r>
-              <a:t>Sequestering Carbon, option B: Same, cream sky. Vector illustration (no AI image generation).</a:t>
+              <a:t>Sequestering Carbon, option B: Same, Organic Cream sky. Vector illustration (no AI image generation).</a:t>
             </a:r>
           </a:p>
         </p:txBody>
@@ -935,7 +935,7 @@
           <a:lstStyle/>
           <a:p>
             <a:r>
-              <a:t>What is the Soil Food Web?, option B: Bean plant with a magnifier on its root zone. Vector illustration (no AI image generation).</a:t>
+              <a:t>What is the Soil Food Web?, option B: Bean plant on Food Web Green, magnifier on its root zone. Vector illustration (no AI image generation).</a:t>
             </a:r>
           </a:p>
         </p:txBody>
@@ -1075,7 +1075,7 @@
           <a:lstStyle/>
           <a:p>
             <a:r>
-              <a:t>Nutrient Cycling, option B: Lettuce with a magnifier on the nutrient loop. Vector illustration (no AI image generation).</a:t>
+              <a:t>Nutrient Cycling, option B: Lettuce on Organic Cream, magnifier on the nutrient loop. Vector illustration (no AI image generation).</a:t>
             </a:r>
           </a:p>
         </p:txBody>
@@ -1145,7 +1145,7 @@
           <a:lstStyle/>
           <a:p>
             <a:r>
-              <a:t>Formation of Structure, option A: Soil crumbs glued by bacteria, woven by fungal threads. Vector illustration (no AI image generation).</a:t>
+              <a:t>Formation of Structure, option A: Soil crumbs glued by bacteria, woven by fungal threads, on Soil Brown. Vector illustration (no AI image generation).</a:t>
             </a:r>
           </a:p>
         </p:txBody>
@@ -1215,7 +1215,7 @@
           <a:lstStyle/>
           <a:p>
             <a:r>
-              <a:t>Formation of Structure, option B: The same crumbs as a specimen on cream. Vector illustration (no AI image generation).</a:t>
+              <a:t>Formation of Structure, option B: The same crumbs as a specimen on Food Web Green. Vector illustration (no AI image generation).</a:t>
             </a:r>
           </a:p>
         </p:txBody>
@@ -1285,7 +1285,7 @@
           <a:lstStyle/>
           <a:p>
             <a:r>
-              <a:t>Weed Suppression, option A: Weeds in bacterial soil vs corn in fungal soil, cream sky. Vector illustration (no AI image generation).</a:t>
+              <a:t>Weed Suppression, option A: Weeds in bacterial soil vs corn in fungal soil; cream and green sky like the reference. Vector illustration (no AI image generation).</a:t>
             </a:r>
           </a:p>
         </p:txBody>
@@ -1355,7 +1355,7 @@
           <a:lstStyle/>
           <a:p>
             <a:r>
-              <a:t>Weed Suppression, option B: Same, cream and deep green sky like the reference. Vector illustration (no AI image generation).</a:t>
+              <a:t>Weed Suppression, option B: Same, Food Web Green sky. Vector illustration (no AI image generation).</a:t>
             </a:r>
           </a:p>
         </p:txBody>
@@ -1425,7 +1425,7 @@
           <a:lstStyle/>
           <a:p>
             <a:r>
-              <a:t>Weed Suppression, option C: Same, pale green sky. Vector illustration (no AI image generation).</a:t>
+              <a:t>Weed Suppression, option C: Same, Organic Cream sky. Vector illustration (no AI image generation).</a:t>
             </a:r>
           </a:p>
         </p:txBody>
@@ -4715,7 +4715,7 @@
       </p:pic>
       <p:pic>
         <p:nvPicPr>
-          <p:cNvPr id="3" name="Logo" descr="formation-of-structure-B-logo.png"/>
+          <p:cNvPr id="3" name="Logo" descr="what-is-the-soil-food-web-A-logo.png"/>
           <p:cNvPicPr>
             <a:picLocks noChangeAspect="1"/>
           </p:cNvPicPr>
@@ -4767,7 +4767,7 @@
             <a:r>
               <a:rPr b="1" sz="4600">
                 <a:solidFill>
-                  <a:srgbClr val="156826"/>
+                  <a:srgbClr val="FFFFFF"/>
                 </a:solidFill>
                 <a:latin typeface="Montserrat"/>
               </a:rPr>
@@ -4783,7 +4783,7 @@
             <a:r>
               <a:rPr b="1" sz="4600">
                 <a:solidFill>
-                  <a:srgbClr val="156826"/>
+                  <a:srgbClr val="FFFFFF"/>
                 </a:solidFill>
                 <a:latin typeface="Montserrat"/>
               </a:rPr>
@@ -5009,7 +5009,7 @@
             <a:r>
               <a:rPr b="1" sz="4600">
                 <a:solidFill>
-                  <a:srgbClr val="156826"/>
+                  <a:srgbClr val="FFFFFF"/>
                 </a:solidFill>
                 <a:latin typeface="Montserrat"/>
               </a:rPr>
@@ -5025,7 +5025,7 @@
             <a:r>
               <a:rPr b="1" sz="4600">
                 <a:solidFill>
-                  <a:srgbClr val="156826"/>
+                  <a:srgbClr val="FFFFFF"/>
                 </a:solidFill>
                 <a:latin typeface="Montserrat"/>
               </a:rPr>
@@ -5251,7 +5251,7 @@
             <a:r>
               <a:rPr b="1" sz="4600">
                 <a:solidFill>
-                  <a:srgbClr val="156826"/>
+                  <a:srgbClr val="FFFFFF"/>
                 </a:solidFill>
                 <a:latin typeface="Montserrat"/>
               </a:rPr>
@@ -5267,7 +5267,7 @@
             <a:r>
               <a:rPr b="1" sz="4600">
                 <a:solidFill>
-                  <a:srgbClr val="156826"/>
+                  <a:srgbClr val="FFFFFF"/>
                 </a:solidFill>
                 <a:latin typeface="Montserrat"/>
               </a:rPr>
@@ -5683,7 +5683,7 @@
       </p:pic>
       <p:pic>
         <p:nvPicPr>
-          <p:cNvPr id="3" name="Logo" descr="formation-of-structure-B-logo.png"/>
+          <p:cNvPr id="3" name="Logo" descr="what-is-the-soil-food-web-A-logo.png"/>
           <p:cNvPicPr>
             <a:picLocks noChangeAspect="1"/>
           </p:cNvPicPr>
@@ -5735,7 +5735,7 @@
             <a:r>
               <a:rPr b="1" sz="4600">
                 <a:solidFill>
-                  <a:srgbClr val="156826"/>
+                  <a:srgbClr val="FFFFFF"/>
                 </a:solidFill>
                 <a:latin typeface="Montserrat"/>
               </a:rPr>
@@ -5751,7 +5751,7 @@
             <a:r>
               <a:rPr b="1" sz="4600">
                 <a:solidFill>
-                  <a:srgbClr val="156826"/>
+                  <a:srgbClr val="FFFFFF"/>
                 </a:solidFill>
                 <a:latin typeface="Montserrat"/>
               </a:rPr>
@@ -5804,7 +5804,7 @@
       </p:pic>
       <p:pic>
         <p:nvPicPr>
-          <p:cNvPr id="3" name="Logo" descr="formation-of-structure-B-logo.png"/>
+          <p:cNvPr id="3" name="Logo" descr="what-is-the-soil-food-web-A-logo.png"/>
           <p:cNvPicPr>
             <a:picLocks noChangeAspect="1"/>
           </p:cNvPicPr>
@@ -5977,7 +5977,7 @@
             <a:r>
               <a:rPr b="1" sz="4600">
                 <a:solidFill>
-                  <a:srgbClr val="156826"/>
+                  <a:srgbClr val="FFFFFF"/>
                 </a:solidFill>
                 <a:latin typeface="Montserrat"/>
               </a:rPr>
@@ -5993,7 +5993,7 @@
             <a:r>
               <a:rPr b="1" sz="4600">
                 <a:solidFill>
-                  <a:srgbClr val="156826"/>
+                  <a:srgbClr val="FFFFFF"/>
                 </a:solidFill>
                 <a:latin typeface="Montserrat"/>
               </a:rPr>
@@ -6046,7 +6046,7 @@
       </p:pic>
       <p:pic>
         <p:nvPicPr>
-          <p:cNvPr id="3" name="Logo" descr="formation-of-structure-B-logo.png"/>
+          <p:cNvPr id="3" name="Logo" descr="weed-suppression-C-logo.png"/>
           <p:cNvPicPr>
             <a:picLocks noChangeAspect="1"/>
           </p:cNvPicPr>

</xml_diff>